<commit_message>
sd-10-028: spell SOLID out as its five principles, in the lesson and on the deck
Co-Authored-By: Claude Opus 5.5 <noreply@anthropic.com>
Claude-Session: https://claude.ai/code/session_01TDEQZkTojRsEuCWxmNaEbL
</commit_message>
<xml_diff>
--- a/system-design-101/vi/lessons/sd-10-028/slides/sd-10-028.pptx
+++ b/system-design-101/vi/lessons/sd-10-028/slides/sd-10-028.pptx
@@ -4083,7 +4083,7 @@
         <p:spPr>
           <a:xfrm>
             <a:off x="1257300" y="7315200"/>
-            <a:ext cx="6953250" cy="323850"/>
+            <a:ext cx="6953250" cy="628650"/>
           </a:xfrm>
           <a:prstGeom prst="rect">
             <a:avLst/>
@@ -4092,10 +4092,13 @@
           <a:ln/>
         </p:spPr>
         <p:txBody>
-          <a:bodyPr wrap="square" lIns="0" tIns="0" rIns="0" bIns="0" rtlCol="0" anchor="t"/>
+          <a:bodyPr wrap="square" lIns="0" tIns="9716" rIns="0" bIns="-9716" rtlCol="0" anchor="t"/>
           <a:lstStyle/>
           <a:p>
             <a:pPr algn="l" indent="0" marL="0">
+              <a:lnSpc>
+                <a:spcPts val="2340"/>
+              </a:lnSpc>
               <a:buNone/>
             </a:pPr>
             <a:r>
@@ -4107,7 +4110,18 @@
                 <a:ea typeface="Be Vietnam Pro" pitchFamily="34" charset="-122"/>
                 <a:cs typeface="Be Vietnam Pro" pitchFamily="34" charset="-120"/>
               </a:rPr>
-              <a:t>Single,</a:t>
+              <a:t>Single</a:t>
+            </a:r>
+            <a:r>
+              <a:rPr lang="en-US" sz="1800" dirty="0" spc="-6" kern="0">
+                <a:solidFill>
+                  <a:srgbClr val="C4C8D6"/>
+                </a:solidFill>
+                <a:latin typeface="Be Vietnam Pro" pitchFamily="34" charset="0"/>
+                <a:ea typeface="Be Vietnam Pro" pitchFamily="34" charset="-122"/>
+                <a:cs typeface="Be Vietnam Pro" pitchFamily="34" charset="-120"/>
+              </a:rPr>
+              <a:t> responsibility,</a:t>
             </a:r>
             <a:r>
               <a:rPr lang="en-US" sz="1800" dirty="0" spc="-3" kern="0">
@@ -4118,10 +4132,10 @@
                 <a:ea typeface="Be Vietnam Pro" pitchFamily="34" charset="-122"/>
                 <a:cs typeface="Be Vietnam Pro" pitchFamily="34" charset="-120"/>
               </a:rPr>
-              <a:t> Open,</a:t>
-            </a:r>
-            <a:r>
-              <a:rPr lang="en-US" sz="1800" dirty="0" spc="-15" kern="0">
+              <a:t> Open-closed,</a:t>
+            </a:r>
+            <a:r>
+              <a:rPr lang="en-US" sz="1800" dirty="0" spc="-17" kern="0">
                 <a:solidFill>
                   <a:srgbClr val="C4C8D6"/>
                 </a:solidFill>
@@ -4129,10 +4143,10 @@
                 <a:ea typeface="Be Vietnam Pro" pitchFamily="34" charset="-122"/>
                 <a:cs typeface="Be Vietnam Pro" pitchFamily="34" charset="-120"/>
               </a:rPr>
-              <a:t> Liskov,</a:t>
-            </a:r>
-            <a:r>
-              <a:rPr lang="en-US" sz="1800" dirty="0" spc="-9" kern="0">
+              <a:t> Liskov</a:t>
+            </a:r>
+            <a:r>
+              <a:rPr lang="en-US" sz="1800" dirty="0" spc="-3" kern="0">
                 <a:solidFill>
                   <a:srgbClr val="C4C8D6"/>
                 </a:solidFill>
@@ -4140,7 +4154,38 @@
                 <a:ea typeface="Be Vietnam Pro" pitchFamily="34" charset="-122"/>
                 <a:cs typeface="Be Vietnam Pro" pitchFamily="34" charset="-120"/>
               </a:rPr>
-              <a:t> Interface,</a:t>
+              <a:t> substitution,</a:t>
+            </a:r>
+            <a:endParaRPr lang="en-US" sz="1800" dirty="0"/>
+          </a:p>
+          <a:p>
+            <a:pPr algn="l" indent="0" marL="0">
+              <a:lnSpc>
+                <a:spcPts val="2340"/>
+              </a:lnSpc>
+              <a:buNone/>
+            </a:pPr>
+            <a:r>
+              <a:rPr lang="en-US" sz="1800" dirty="0" spc="-11" kern="0">
+                <a:solidFill>
+                  <a:srgbClr val="C4C8D6"/>
+                </a:solidFill>
+                <a:latin typeface="Be Vietnam Pro" pitchFamily="34" charset="0"/>
+                <a:ea typeface="Be Vietnam Pro" pitchFamily="34" charset="-122"/>
+                <a:cs typeface="Be Vietnam Pro" pitchFamily="34" charset="-120"/>
+              </a:rPr>
+              <a:t>Interface</a:t>
+            </a:r>
+            <a:r>
+              <a:rPr lang="en-US" sz="1800" dirty="0" spc="-14" kern="0">
+                <a:solidFill>
+                  <a:srgbClr val="C4C8D6"/>
+                </a:solidFill>
+                <a:latin typeface="Be Vietnam Pro" pitchFamily="34" charset="0"/>
+                <a:ea typeface="Be Vietnam Pro" pitchFamily="34" charset="-122"/>
+                <a:cs typeface="Be Vietnam Pro" pitchFamily="34" charset="-120"/>
+              </a:rPr>
+              <a:t> segregation,</a:t>
             </a:r>
             <a:r>
               <a:rPr lang="en-US" sz="1800" dirty="0" spc="-6" kern="0">
@@ -4153,6 +4198,17 @@
               </a:rPr>
               <a:t> Dependency</a:t>
             </a:r>
+            <a:r>
+              <a:rPr lang="en-US" sz="1800" dirty="0" spc="-7" kern="0">
+                <a:solidFill>
+                  <a:srgbClr val="C4C8D6"/>
+                </a:solidFill>
+                <a:latin typeface="Be Vietnam Pro" pitchFamily="34" charset="0"/>
+                <a:ea typeface="Be Vietnam Pro" pitchFamily="34" charset="-122"/>
+                <a:cs typeface="Be Vietnam Pro" pitchFamily="34" charset="-120"/>
+              </a:rPr>
+              <a:t> inversion</a:t>
+            </a:r>
             <a:endParaRPr lang="en-US" sz="1800" dirty="0"/>
           </a:p>
         </p:txBody>
@@ -4165,8 +4221,8 @@
         </p:nvSpPr>
         <p:spPr>
           <a:xfrm>
-            <a:off x="1257300" y="7734300"/>
-            <a:ext cx="6953250" cy="723900"/>
+            <a:off x="1257300" y="8039100"/>
+            <a:ext cx="6953250" cy="381000"/>
           </a:xfrm>
           <a:prstGeom prst="rect">
             <a:avLst/>

</xml_diff>